<commit_message>
slides: slide 5 -- drop handheld panel, expand HackRF TX details
Replaced the 'Dual-Band Handheld' panel with a 'TX Capabilities' panel:
the two TX gain stages (on/off RF amp ~+11 dB, VGA/IF 0-47 dB in 1 dB
steps), realistic max output power by frequency band (+5 to +15 dBm
below 2.17 GHz, dropping toward 0-10 dBm up to 4 GHz), how that maps to
this talk's conservative default TX gain, and a note that there's no
built-in per-band TX filtering. Sourced from hackrf.readthedocs.io and
greatscottgadgets.com/hackrf/one. Slide title simplified to 'HackRF One'.
Still 19 slides total, re-validated bounds.

Co-Authored-By: Claude Sonnet 5 <noreply@anthropic.com>
</commit_message>
<xml_diff>
--- a/slides/SDR_Demo.pptx
+++ b/slides/SDR_Demo.pptx
@@ -10799,7 +10799,7 @@
                 </a:solidFill>
                 <a:latin typeface="Calibri"/>
               </a:rPr>
-              <a:t>HackRF One + Ham Handheld</a:t>
+              <a:t>HackRF One</a:t>
             </a:r>
           </a:p>
         </p:txBody>
@@ -10930,7 +10930,7 @@
                 </a:solidFill>
                 <a:latin typeface="Calibri"/>
               </a:rPr>
-              <a:t>HackRF One</a:t>
+              <a:t>Core Specs</a:t>
             </a:r>
           </a:p>
         </p:txBody>
@@ -10991,7 +10991,7 @@
                 </a:solidFill>
                 <a:latin typeface="Calibri"/>
               </a:rPr>
-              <a:t>•  Up to 20 Msps, 8-bit ADC/DAC</a:t>
+              <a:t>•  Up to 20 Msps, 8-bit quadrature ADC/DAC (8-bit I, 8-bit Q)</a:t>
             </a:r>
           </a:p>
           <a:p>
@@ -11010,7 +11010,7 @@
                 </a:solidFill>
                 <a:latin typeface="Calibri"/>
               </a:rPr>
-              <a:t>•  Half-duplex (RX or TX, not both at once)</a:t>
+              <a:t>•  Half-duplex (RX or TX, never both at once)</a:t>
             </a:r>
           </a:p>
           <a:p>
@@ -11029,7 +11029,7 @@
                 </a:solidFill>
                 <a:latin typeface="Calibri"/>
               </a:rPr>
-              <a:t>•  USB-powered, open source hardware</a:t>
+              <a:t>•  Hi-Speed USB 2.0, USB-powered, open source hardware</a:t>
             </a:r>
           </a:p>
           <a:p>
@@ -11135,7 +11135,7 @@
                 </a:solidFill>
                 <a:latin typeface="Calibri"/>
               </a:rPr>
-              <a:t>Dual-Band Handheld (144/440)</a:t>
+              <a:t>TX Capabilities</a:t>
             </a:r>
           </a:p>
         </p:txBody>
@@ -11167,17 +11167,17 @@
                 <a:spcPct val="112000"/>
               </a:lnSpc>
               <a:spcAft>
-                <a:spcPts val="1200"/>
+                <a:spcPts val="1000"/>
               </a:spcAft>
             </a:pPr>
             <a:r>
-              <a:rPr sz="1600">
+              <a:rPr sz="1500">
                 <a:solidFill>
                   <a:srgbClr val="D7E3EC"/>
                 </a:solidFill>
                 <a:latin typeface="Calibri"/>
               </a:rPr>
-              <a:t>•  Our “known-good” reference radio</a:t>
+              <a:t>•  Two software-controlled TX gain stages -- no physical knobs: an on/off RF amp (~+11 dB) and a VGA/IF gain stage, 0-47 dB in 1 dB steps.</a:t>
             </a:r>
           </a:p>
           <a:p>
@@ -11186,17 +11186,17 @@
                 <a:spcPct val="112000"/>
               </a:lnSpc>
               <a:spcAft>
-                <a:spcPts val="1200"/>
+                <a:spcPts val="1000"/>
               </a:spcAft>
             </a:pPr>
             <a:r>
-              <a:rPr sz="1600">
+              <a:rPr sz="1500">
                 <a:solidFill>
                   <a:srgbClr val="D7E3EC"/>
                 </a:solidFill>
                 <a:latin typeface="Calibri"/>
               </a:rPr>
-              <a:t>•  2m (144-148 MHz) and 70cm (420-450 MHz)</a:t>
+              <a:t>•  Max output power varies with frequency -- roughly +5 to +15 dBm from 1 MHz-2.17 GHz, dropping to about 0-10 dBm up through 4 GHz. Best performance is actually 2170-2740 MHz.</a:t>
             </a:r>
           </a:p>
           <a:p>
@@ -11205,17 +11205,17 @@
                 <a:spcPct val="112000"/>
               </a:lnSpc>
               <a:spcAft>
-                <a:spcPts val="1200"/>
+                <a:spcPts val="1000"/>
               </a:spcAft>
             </a:pPr>
             <a:r>
-              <a:rPr sz="1600">
+              <a:rPr sz="1500">
                 <a:solidFill>
                   <a:srgbClr val="D7E3EC"/>
                 </a:solidFill>
                 <a:latin typeface="Calibri"/>
               </a:rPr>
-              <a:t>•  Keys up so we can watch/hear the HackRF receive it</a:t>
+              <a:t>•  Tonight's TX demos default to just 10 dB of VGA gain -- comfortably at the low end, per the "minimum power necessary" guidance.</a:t>
             </a:r>
           </a:p>
           <a:p>
@@ -11224,17 +11224,17 @@
                 <a:spcPct val="112000"/>
               </a:lnSpc>
               <a:spcAft>
-                <a:spcPts val="1200"/>
+                <a:spcPts val="1000"/>
               </a:spcAft>
             </a:pPr>
             <a:r>
-              <a:rPr sz="1600">
+              <a:rPr sz="1500">
                 <a:solidFill>
                   <a:srgbClr val="D7E3EC"/>
                 </a:solidFill>
                 <a:latin typeface="Calibri"/>
               </a:rPr>
-              <a:t>•  Receives our HackRF transmissions in the reverse demos</a:t>
+              <a:t>•  No built-in per-band TX filtering -- it's a general-purpose transmitter, so staying inside our allocated ham segments is on us.</a:t>
             </a:r>
           </a:p>
         </p:txBody>
@@ -11248,7 +11248,7 @@
         <p:spPr>
           <a:xfrm>
             <a:off x="640080" y="6473952"/>
-            <a:ext cx="7315200" cy="274320"/>
+            <a:ext cx="8229600" cy="274320"/>
           </a:xfrm>
           <a:prstGeom prst="rect">
             <a:avLst/>
@@ -11267,13 +11267,13 @@
               </a:lnSpc>
             </a:pPr>
             <a:r>
-              <a:rPr sz="1000" b="0" i="0">
+              <a:rPr sz="1000" b="0" i="1">
                 <a:solidFill>
                   <a:srgbClr val="8EA7BA"/>
                 </a:solidFill>
                 <a:latin typeface="Calibri"/>
               </a:rPr>
-              <a:t>SDR Demo -- GNU Radio + HackRF + Ham Handheld</a:t>
+              <a:t>Sources: hackrf.readthedocs.io, greatscottgadgets.com/hackrf/one</a:t>
             </a:r>
           </a:p>
         </p:txBody>

</xml_diff>

<commit_message>
slides: strip presenter-facing instructions from demo slides
Removed everything that was really a stage direction rather than
audience content: 'Flowgraph: X.grc' filename references, explicit
'Talking point:' labels, imperative operational steps ('retype the
frequency box', 'hit Execute, key up the handheld'), and the Demo 4
skip-guidance line. Rewrote each demo slide's bullets as clean,
descriptive audience-facing content covering the same substance. All of
what was removed is being captured (and expanded) in a new presenter's
guide document.

Co-Authored-By: Claude Sonnet 5 <noreply@anthropic.com>
</commit_message>
<xml_diff>
--- a/slides/SDR_Demo.pptx
+++ b/slides/SDR_Demo.pptx
@@ -3626,7 +3626,7 @@
                 </a:solidFill>
                 <a:latin typeface="Calibri"/>
               </a:rPr>
-              <a:t>•  Flowgraph: 02_nbfm_voice_receiver.grc</a:t>
+              <a:t>•  A real narrowband FM voice receiver -- channel filter, resampler, FM demodulator, straight to the speakers.</a:t>
             </a:r>
           </a:p>
           <a:p>
@@ -3645,7 +3645,7 @@
                 </a:solidFill>
                 <a:latin typeface="Calibri"/>
               </a:rPr>
-              <a:t>•  A real narrowband FM voice receiver -- channel filter, resampler, FM demodulator, straight to the speakers.</a:t>
+              <a:t>•  Tuned to 146.520 MHz, the national 2m simplex calling frequency.</a:t>
             </a:r>
           </a:p>
           <a:p>
@@ -3664,26 +3664,7 @@
                 </a:solidFill>
                 <a:latin typeface="Calibri"/>
               </a:rPr>
-              <a:t>•  Default: 146.520 MHz, the national 2m simplex calling frequency. Key up the handheld there and it comes through the laptop.</a:t>
-            </a:r>
-          </a:p>
-          <a:p>
-            <a:pPr>
-              <a:lnSpc>
-                <a:spcPct val="112000"/>
-              </a:lnSpc>
-              <a:spcAft>
-                <a:spcPts val="1600"/>
-              </a:spcAft>
-            </a:pPr>
-            <a:r>
-              <a:rPr sz="1900">
-                <a:solidFill>
-                  <a:srgbClr val="D7E3EC"/>
-                </a:solidFill>
-                <a:latin typeface="Calibri"/>
-              </a:rPr>
-              <a:t>•  Talking point: this whole receiver -- the part that's a dedicated chip in a normal radio -- is about a dozen blocks of software here.</a:t>
+              <a:t>•  This whole receiver -- normally a dedicated chip in an off-the-shelf radio -- is about a dozen blocks of software here.</a:t>
             </a:r>
           </a:p>
         </p:txBody>
@@ -3987,25 +3968,6 @@
                 </a:solidFill>
                 <a:latin typeface="Calibri"/>
               </a:rPr>
-              <a:t>•  Flowgraph: 03_record_2m_band_to_file.grc</a:t>
-            </a:r>
-          </a:p>
-          <a:p>
-            <a:pPr>
-              <a:lnSpc>
-                <a:spcPct val="112000"/>
-              </a:lnSpc>
-              <a:spcAft>
-                <a:spcPts val="1600"/>
-              </a:spcAft>
-            </a:pPr>
-            <a:r>
-              <a:rPr sz="1900">
-                <a:solidFill>
-                  <a:srgbClr val="D7E3EC"/>
-                </a:solidFill>
-                <a:latin typeface="Calibri"/>
-              </a:rPr>
               <a:t>•  Tunes to 146.0 MHz center at 6 Msps -- covers 143.0 to 149.0 MHz, the whole 144-148 MHz 2m band with margin to spare.</a:t>
             </a:r>
           </a:p>
@@ -4060,7 +4022,7 @@
                 </a:solidFill>
                 <a:latin typeface="Calibri"/>
               </a:rPr>
-              <a:t>•  Live: hit Execute, key up the handheld once or twice, hit Stop. ~2.9 GB/minute -- a 20-30 second capture is plenty for the demo.</a:t>
+              <a:t>•  A single recording captures everything transmitted on the band during that window -- roughly 2.9 GB per minute at this sample rate.</a:t>
             </a:r>
           </a:p>
         </p:txBody>
@@ -4419,7 +4381,7 @@
                 </a:solidFill>
                 <a:latin typeface="Calibri"/>
               </a:rPr>
-              <a:t>•  Flowgraph: 04_playback_2m_band_from_file.grc</a:t>
+              <a:t>•  Reads the file back and feeds it straight into the HackRF's transmitter -- the exact recorded band reappears on the air.</a:t>
             </a:r>
           </a:p>
           <a:p>
@@ -4438,26 +4400,7 @@
                 </a:solidFill>
                 <a:latin typeface="Calibri"/>
               </a:rPr>
-              <a:t>•  Reads the file back and feeds it straight into the HackRF's transmitter -- the exact recorded band reappears on the air.</a:t>
-            </a:r>
-          </a:p>
-          <a:p>
-            <a:pPr>
-              <a:lnSpc>
-                <a:spcPct val="112000"/>
-              </a:lnSpc>
-              <a:spcAft>
-                <a:spcPts val="1600"/>
-              </a:spcAft>
-            </a:pPr>
-            <a:r>
-              <a:rPr sz="1900">
-                <a:solidFill>
-                  <a:srgbClr val="D7E3EC"/>
-                </a:solidFill>
-                <a:latin typeface="Calibri"/>
-              </a:rPr>
-              <a:t>•  Watch the waterfall reproduce exactly what was captured; the handheld hears the same signal a second time, live.</a:t>
+              <a:t>•  The waterfall reproduces exactly what was captured; the handheld hears the same signal a second time, live.</a:t>
             </a:r>
           </a:p>
           <a:p>
@@ -5215,7 +5158,7 @@
                 </a:solidFill>
                 <a:latin typeface="Calibri"/>
               </a:rPr>
-              <a:t>•  Flowgraph: 05_nbfm_voice_transmitter.grc</a:t>
+              <a:t>•  The reverse direction: laptop microphone → NBFM modulator → HackRF → antenna.</a:t>
             </a:r>
           </a:p>
           <a:p>
@@ -5234,45 +5177,7 @@
                 </a:solidFill>
                 <a:latin typeface="Calibri"/>
               </a:rPr>
-              <a:t>•  The reverse direction: laptop microphone → NBFM modulator → HackRF → antenna.</a:t>
-            </a:r>
-          </a:p>
-          <a:p>
-            <a:pPr>
-              <a:lnSpc>
-                <a:spcPct val="112000"/>
-              </a:lnSpc>
-              <a:spcAft>
-                <a:spcPts val="1600"/>
-              </a:spcAft>
-            </a:pPr>
-            <a:r>
-              <a:rPr sz="1900">
-                <a:solidFill>
-                  <a:srgbClr val="D7E3EC"/>
-                </a:solidFill>
-                <a:latin typeface="Calibri"/>
-              </a:rPr>
-              <a:t>•  Talk into the laptop, hear yourself on the handheld -- live two-way, same 146.520 MHz simplex frequency as Demo 2.</a:t>
-            </a:r>
-          </a:p>
-          <a:p>
-            <a:pPr>
-              <a:lnSpc>
-                <a:spcPct val="112000"/>
-              </a:lnSpc>
-              <a:spcAft>
-                <a:spcPts val="1600"/>
-              </a:spcAft>
-            </a:pPr>
-            <a:r>
-              <a:rPr sz="1900">
-                <a:solidFill>
-                  <a:srgbClr val="D7E3EC"/>
-                </a:solidFill>
-                <a:latin typeface="Calibri"/>
-              </a:rPr>
-              <a:t>•  Skip this one if there's no control operator in the room -- Demos 0-3 already tell the full story.</a:t>
+              <a:t>•  Live two-way on the same 146.520 MHz simplex frequency as Demo 2.</a:t>
             </a:r>
           </a:p>
         </p:txBody>
@@ -13197,7 +13102,7 @@
                 </a:solidFill>
                 <a:latin typeface="Calibri"/>
               </a:rPr>
-              <a:t>•  Flowgraph: 06_bonus_fm_broadcast_receiver.grc</a:t>
+              <a:t>•  A quick tune to any strong local FM station brings music through the laptop speakers, instantly.</a:t>
             </a:r>
           </a:p>
           <a:p>
@@ -13216,26 +13121,7 @@
                 </a:solidFill>
                 <a:latin typeface="Calibri"/>
               </a:rPr>
-              <a:t>•  Tune to any strong local FM station (88-108 MHz) and hear music instantly through the laptop speakers.</a:t>
-            </a:r>
-          </a:p>
-          <a:p>
-            <a:pPr>
-              <a:lnSpc>
-                <a:spcPct val="112000"/>
-              </a:lnSpc>
-              <a:spcAft>
-                <a:spcPts val="1600"/>
-              </a:spcAft>
-            </a:pPr>
-            <a:r>
-              <a:rPr sz="1900">
-                <a:solidFill>
-                  <a:srgbClr val="D7E3EC"/>
-                </a:solidFill>
-                <a:latin typeface="Calibri"/>
-              </a:rPr>
-              <a:t>•  Not a ham-band demo -- it's here to prove the whole chain works (driver, HackRF, GNU Radio, audio out) before the ham material, and it needs no license to receive.</a:t>
+              <a:t>•  Not a ham-band demo -- it proves the whole chain works (driver, HackRF, GNU Radio, audio out) before the ham material, and it needs no license to receive.</a:t>
             </a:r>
           </a:p>
         </p:txBody>
@@ -13594,7 +13480,7 @@
                 </a:solidFill>
                 <a:latin typeface="Calibri"/>
               </a:rPr>
-              <a:t>•  Flowgraph: 01_spectrum_waterfall_tunable.grc</a:t>
+              <a:t>•  One flowgraph covers both ham bands -- we'll retune live between 2m and 70cm.</a:t>
             </a:r>
           </a:p>
           <a:p>
@@ -13613,7 +13499,7 @@
                 </a:solidFill>
                 <a:latin typeface="Calibri"/>
               </a:rPr>
-              <a:t>•  One flowgraph, both ham bands -- retype the center frequency live: 146.520 MHz (2m) then 446.000 MHz (70cm).</a:t>
+              <a:t>•  Watch the spectrum plot and waterfall light up in real time as a handheld transmission appears.</a:t>
             </a:r>
           </a:p>
           <a:p>
@@ -13632,26 +13518,7 @@
                 </a:solidFill>
                 <a:latin typeface="Calibri"/>
               </a:rPr>
-              <a:t>•  Key up the handheld on each band and watch the signal light up the spectrum plot and waterfall in real time.</a:t>
-            </a:r>
-          </a:p>
-          <a:p>
-            <a:pPr>
-              <a:lnSpc>
-                <a:spcPct val="112000"/>
-              </a:lnSpc>
-              <a:spcAft>
-                <a:spcPts val="1600"/>
-              </a:spcAft>
-            </a:pPr>
-            <a:r>
-              <a:rPr sz="1900">
-                <a:solidFill>
-                  <a:srgbClr val="D7E3EC"/>
-                </a:solidFill>
-                <a:latin typeface="Calibri"/>
-              </a:rPr>
-              <a:t>•  Talking point: this is the same 10 MHz of RF spectrum a traditional radio can only look at one narrow slice of at a time.</a:t>
+              <a:t>•  It's the same slice of RF spectrum a traditional radio can only look at one narrow channel of at a time.</a:t>
             </a:r>
           </a:p>
         </p:txBody>

</xml_diff>

<commit_message>
slides: drop 'How We Used It Tonight' from slide 15
Slide 15 is now a single full-width panel -- just 'What It Actually Is'
(history, architecture, block library), retitled from 'GNU Radio: What
It Is, How It's Used' to 'GNU Radio: What It Actually Is'. Dropped the
bordered-panel styling in favor of the plain full-width bullet style
used by other single-topic slides (4, 17, 20) now that there's only one
column of content.

PRESENTER_NOTES.md: updated the slide 15 row, and noted that the timing
budget is a floor, not a ceiling -- the deck growing past a 20-30 minute
slot is fine, the cut-list is there so any given presentation can be
trimmed to whatever slot is actually available.

Co-Authored-By: Claude Sonnet 5 <noreply@anthropic.com>
</commit_message>
<xml_diff>
--- a/slides/SDR_Demo.pptx
+++ b/slides/SDR_Demo.pptx
@@ -5397,7 +5397,7 @@
                 </a:solidFill>
                 <a:latin typeface="Calibri"/>
               </a:rPr>
-              <a:t>GNU Radio: What It Is, How It's Used</a:t>
+              <a:t>GNU Radio: What It Actually Is</a:t>
             </a:r>
           </a:p>
         </p:txBody>
@@ -5448,49 +5448,100 @@
       </p:sp>
       <p:sp>
         <p:nvSpPr>
-          <p:cNvPr id="6" name="Rounded Rectangle 5"/>
-          <p:cNvSpPr/>
+          <p:cNvPr id="6" name="TextBox 5"/>
+          <p:cNvSpPr txBox="1"/>
           <p:nvPr/>
         </p:nvSpPr>
         <p:spPr>
           <a:xfrm>
             <a:off x="640080" y="1920240"/>
-            <a:ext cx="5212080" cy="4114800"/>
-          </a:xfrm>
-          <a:prstGeom prst="roundRect">
-            <a:avLst>
-              <a:gd name="adj" fmla="val 4000"/>
-            </a:avLst>
-          </a:prstGeom>
-          <a:solidFill>
-            <a:srgbClr val="0F2438"/>
-          </a:solidFill>
-          <a:ln w="12700">
-            <a:solidFill>
-              <a:srgbClr val="1B5E58"/>
-            </a:solidFill>
-          </a:ln>
-          <a:effectLst/>
-        </p:spPr>
-        <p:style>
-          <a:lnRef idx="1">
-            <a:schemeClr val="accent1"/>
-          </a:lnRef>
-          <a:fillRef idx="3">
-            <a:schemeClr val="accent1"/>
-          </a:fillRef>
-          <a:effectRef idx="2">
-            <a:schemeClr val="accent1"/>
-          </a:effectRef>
-          <a:fontRef idx="minor">
-            <a:schemeClr val="lt1"/>
-          </a:fontRef>
-        </p:style>
-        <p:txBody>
-          <a:bodyPr rtlCol="0" anchor="ctr"/>
-          <a:lstStyle/>
-          <a:p>
-            <a:pPr algn="ctr"/>
+            <a:ext cx="10698480" cy="4114800"/>
+          </a:xfrm>
+          <a:prstGeom prst="rect">
+            <a:avLst/>
+          </a:prstGeom>
+          <a:noFill/>
+        </p:spPr>
+        <p:txBody>
+          <a:bodyPr wrap="square">
+            <a:spAutoFit/>
+          </a:bodyPr>
+          <a:lstStyle/>
+          <a:p>
+            <a:pPr>
+              <a:lnSpc>
+                <a:spcPct val="112000"/>
+              </a:lnSpc>
+              <a:spcAft>
+                <a:spcPts val="1600"/>
+              </a:spcAft>
+            </a:pPr>
+            <a:r>
+              <a:rPr sz="1900">
+                <a:solidFill>
+                  <a:srgbClr val="D7E3EC"/>
+                </a:solidFill>
+                <a:latin typeface="Calibri"/>
+              </a:rPr>
+              <a:t>•  Started in 2001 (Eric Blossom); now stewarded by the GNU Radio Project and the GNU Radio Foundation.</a:t>
+            </a:r>
+          </a:p>
+          <a:p>
+            <a:pPr>
+              <a:lnSpc>
+                <a:spcPct val="112000"/>
+              </a:lnSpc>
+              <a:spcAft>
+                <a:spcPts val="1600"/>
+              </a:spcAft>
+            </a:pPr>
+            <a:r>
+              <a:rPr sz="1900">
+                <a:solidFill>
+                  <a:srgbClr val="D7E3EC"/>
+                </a:solidFill>
+                <a:latin typeface="Calibri"/>
+              </a:rPr>
+              <a:t>•  C++ underneath for real-time DSP performance; Python (and GNU Radio Companion) on top for building and scripting flowgraphs.</a:t>
+            </a:r>
+          </a:p>
+          <a:p>
+            <a:pPr>
+              <a:lnSpc>
+                <a:spcPct val="112000"/>
+              </a:lnSpc>
+              <a:spcAft>
+                <a:spcPts val="1600"/>
+              </a:spcAft>
+            </a:pPr>
+            <a:r>
+              <a:rPr sz="1900">
+                <a:solidFill>
+                  <a:srgbClr val="D7E3EC"/>
+                </a:solidFill>
+                <a:latin typeface="Calibri"/>
+              </a:rPr>
+              <a:t>•  A scheduler manages sample buffers between blocks -- the same runtime whether the samples are live from a HackRF or read back from a file.</a:t>
+            </a:r>
+          </a:p>
+          <a:p>
+            <a:pPr>
+              <a:lnSpc>
+                <a:spcPct val="112000"/>
+              </a:lnSpc>
+              <a:spcAft>
+                <a:spcPts val="1600"/>
+              </a:spcAft>
+            </a:pPr>
+            <a:r>
+              <a:rPr sz="1900">
+                <a:solidFill>
+                  <a:srgbClr val="D7E3EC"/>
+                </a:solidFill>
+                <a:latin typeface="Calibri"/>
+              </a:rPr>
+              <a:t>•  Hundreds of built-in blocks -- filters, modulators, channel coding, synchronization -- plus a large ecosystem of out-of-tree (OOT) modules for specific protocols.</a:t>
+            </a:r>
           </a:p>
         </p:txBody>
       </p:sp>
@@ -5502,8 +5553,8 @@
         </p:nvSpPr>
         <p:spPr>
           <a:xfrm>
-            <a:off x="960120" y="2148840"/>
-            <a:ext cx="4572000" cy="365760"/>
+            <a:off x="640080" y="6473952"/>
+            <a:ext cx="8229600" cy="274320"/>
           </a:xfrm>
           <a:prstGeom prst="rect">
             <a:avLst/>
@@ -5522,13 +5573,13 @@
               </a:lnSpc>
             </a:pPr>
             <a:r>
-              <a:rPr sz="1900" b="1" i="0">
-                <a:solidFill>
-                  <a:srgbClr val="35D0BA"/>
-                </a:solidFill>
-                <a:latin typeface="Calibri"/>
-              </a:rPr>
-              <a:t>What It Actually Is</a:t>
+              <a:rPr sz="1000" b="0" i="1">
+                <a:solidFill>
+                  <a:srgbClr val="8EA7BA"/>
+                </a:solidFill>
+                <a:latin typeface="Calibri"/>
+              </a:rPr>
+              <a:t>Source: gnuradio.org -- GNU Radio Conference (GRCon) happens every year</a:t>
             </a:r>
           </a:p>
         </p:txBody>
@@ -5536,330 +5587,6 @@
       <p:sp>
         <p:nvSpPr>
           <p:cNvPr id="8" name="TextBox 7"/>
-          <p:cNvSpPr txBox="1"/>
-          <p:nvPr/>
-        </p:nvSpPr>
-        <p:spPr>
-          <a:xfrm>
-            <a:off x="960120" y="2606040"/>
-            <a:ext cx="4572000" cy="3200400"/>
-          </a:xfrm>
-          <a:prstGeom prst="rect">
-            <a:avLst/>
-          </a:prstGeom>
-          <a:noFill/>
-        </p:spPr>
-        <p:txBody>
-          <a:bodyPr wrap="square">
-            <a:spAutoFit/>
-          </a:bodyPr>
-          <a:lstStyle/>
-          <a:p>
-            <a:pPr>
-              <a:lnSpc>
-                <a:spcPct val="112000"/>
-              </a:lnSpc>
-              <a:spcAft>
-                <a:spcPts val="1000"/>
-              </a:spcAft>
-            </a:pPr>
-            <a:r>
-              <a:rPr sz="1500">
-                <a:solidFill>
-                  <a:srgbClr val="D7E3EC"/>
-                </a:solidFill>
-                <a:latin typeface="Calibri"/>
-              </a:rPr>
-              <a:t>•  Started in 2001 (Eric Blossom); now stewarded by the GNU Radio Project and the GNU Radio Foundation.</a:t>
-            </a:r>
-          </a:p>
-          <a:p>
-            <a:pPr>
-              <a:lnSpc>
-                <a:spcPct val="112000"/>
-              </a:lnSpc>
-              <a:spcAft>
-                <a:spcPts val="1000"/>
-              </a:spcAft>
-            </a:pPr>
-            <a:r>
-              <a:rPr sz="1500">
-                <a:solidFill>
-                  <a:srgbClr val="D7E3EC"/>
-                </a:solidFill>
-                <a:latin typeface="Calibri"/>
-              </a:rPr>
-              <a:t>•  C++ underneath for real-time DSP performance; Python (and GNU Radio Companion) on top for building and scripting flowgraphs.</a:t>
-            </a:r>
-          </a:p>
-          <a:p>
-            <a:pPr>
-              <a:lnSpc>
-                <a:spcPct val="112000"/>
-              </a:lnSpc>
-              <a:spcAft>
-                <a:spcPts val="1000"/>
-              </a:spcAft>
-            </a:pPr>
-            <a:r>
-              <a:rPr sz="1500">
-                <a:solidFill>
-                  <a:srgbClr val="D7E3EC"/>
-                </a:solidFill>
-                <a:latin typeface="Calibri"/>
-              </a:rPr>
-              <a:t>•  A scheduler manages sample buffers between blocks -- the same runtime whether the samples are live from a HackRF or read back from a file.</a:t>
-            </a:r>
-          </a:p>
-          <a:p>
-            <a:pPr>
-              <a:lnSpc>
-                <a:spcPct val="112000"/>
-              </a:lnSpc>
-              <a:spcAft>
-                <a:spcPts val="1000"/>
-              </a:spcAft>
-            </a:pPr>
-            <a:r>
-              <a:rPr sz="1500">
-                <a:solidFill>
-                  <a:srgbClr val="D7E3EC"/>
-                </a:solidFill>
-                <a:latin typeface="Calibri"/>
-              </a:rPr>
-              <a:t>•  Hundreds of built-in blocks -- filters, modulators, channel coding, synchronization -- plus a large ecosystem of out-of-tree (OOT) modules for specific protocols.</a:t>
-            </a:r>
-          </a:p>
-        </p:txBody>
-      </p:sp>
-      <p:sp>
-        <p:nvSpPr>
-          <p:cNvPr id="9" name="Rounded Rectangle 8"/>
-          <p:cNvSpPr/>
-          <p:nvPr/>
-        </p:nvSpPr>
-        <p:spPr>
-          <a:xfrm>
-            <a:off x="6309360" y="1920240"/>
-            <a:ext cx="5212080" cy="4114800"/>
-          </a:xfrm>
-          <a:prstGeom prst="roundRect">
-            <a:avLst>
-              <a:gd name="adj" fmla="val 4000"/>
-            </a:avLst>
-          </a:prstGeom>
-          <a:solidFill>
-            <a:srgbClr val="0F2438"/>
-          </a:solidFill>
-          <a:ln w="12700">
-            <a:solidFill>
-              <a:srgbClr val="1B5E58"/>
-            </a:solidFill>
-          </a:ln>
-          <a:effectLst/>
-        </p:spPr>
-        <p:style>
-          <a:lnRef idx="1">
-            <a:schemeClr val="accent1"/>
-          </a:lnRef>
-          <a:fillRef idx="3">
-            <a:schemeClr val="accent1"/>
-          </a:fillRef>
-          <a:effectRef idx="2">
-            <a:schemeClr val="accent1"/>
-          </a:effectRef>
-          <a:fontRef idx="minor">
-            <a:schemeClr val="lt1"/>
-          </a:fontRef>
-        </p:style>
-        <p:txBody>
-          <a:bodyPr rtlCol="0" anchor="ctr"/>
-          <a:lstStyle/>
-          <a:p>
-            <a:pPr algn="ctr"/>
-          </a:p>
-        </p:txBody>
-      </p:sp>
-      <p:sp>
-        <p:nvSpPr>
-          <p:cNvPr id="10" name="TextBox 9"/>
-          <p:cNvSpPr txBox="1"/>
-          <p:nvPr/>
-        </p:nvSpPr>
-        <p:spPr>
-          <a:xfrm>
-            <a:off x="6629400" y="2148840"/>
-            <a:ext cx="4572000" cy="365760"/>
-          </a:xfrm>
-          <a:prstGeom prst="rect">
-            <a:avLst/>
-          </a:prstGeom>
-          <a:noFill/>
-        </p:spPr>
-        <p:txBody>
-          <a:bodyPr wrap="square" anchor="t" lIns="0" rIns="0" tIns="0" bIns="0">
-            <a:spAutoFit/>
-          </a:bodyPr>
-          <a:lstStyle/>
-          <a:p>
-            <a:pPr algn="l">
-              <a:lnSpc>
-                <a:spcPct val="115000"/>
-              </a:lnSpc>
-            </a:pPr>
-            <a:r>
-              <a:rPr sz="1900" b="1" i="0">
-                <a:solidFill>
-                  <a:srgbClr val="35D0BA"/>
-                </a:solidFill>
-                <a:latin typeface="Calibri"/>
-              </a:rPr>
-              <a:t>How We Used It Tonight</a:t>
-            </a:r>
-          </a:p>
-        </p:txBody>
-      </p:sp>
-      <p:sp>
-        <p:nvSpPr>
-          <p:cNvPr id="11" name="TextBox 10"/>
-          <p:cNvSpPr txBox="1"/>
-          <p:nvPr/>
-        </p:nvSpPr>
-        <p:spPr>
-          <a:xfrm>
-            <a:off x="6629400" y="2606040"/>
-            <a:ext cx="4572000" cy="3200400"/>
-          </a:xfrm>
-          <a:prstGeom prst="rect">
-            <a:avLst/>
-          </a:prstGeom>
-          <a:noFill/>
-        </p:spPr>
-        <p:txBody>
-          <a:bodyPr wrap="square">
-            <a:spAutoFit/>
-          </a:bodyPr>
-          <a:lstStyle/>
-          <a:p>
-            <a:pPr>
-              <a:lnSpc>
-                <a:spcPct val="112000"/>
-              </a:lnSpc>
-              <a:spcAft>
-                <a:spcPts val="1000"/>
-              </a:spcAft>
-            </a:pPr>
-            <a:r>
-              <a:rPr sz="1500">
-                <a:solidFill>
-                  <a:srgbClr val="D7E3EC"/>
-                </a:solidFill>
-                <a:latin typeface="Calibri"/>
-              </a:rPr>
-              <a:t>•  Every demo was the same runtime, different flowgraph -- GRC just generates the Python self.connect(...) calls behind those block diagrams.</a:t>
-            </a:r>
-          </a:p>
-          <a:p>
-            <a:pPr>
-              <a:lnSpc>
-                <a:spcPct val="112000"/>
-              </a:lnSpc>
-              <a:spcAft>
-                <a:spcPts val="1000"/>
-              </a:spcAft>
-            </a:pPr>
-            <a:r>
-              <a:rPr sz="1500">
-                <a:solidFill>
-                  <a:srgbClr val="D7E3EC"/>
-                </a:solidFill>
-                <a:latin typeface="Calibri"/>
-              </a:rPr>
-              <a:t>•  SoapySDR blocks are what actually talked to the HackRF -- swap that one block and the same flowgraph can drive different hardware.</a:t>
-            </a:r>
-          </a:p>
-          <a:p>
-            <a:pPr>
-              <a:lnSpc>
-                <a:spcPct val="112000"/>
-              </a:lnSpc>
-              <a:spcAft>
-                <a:spcPts val="1000"/>
-              </a:spcAft>
-            </a:pPr>
-            <a:r>
-              <a:rPr sz="1500">
-                <a:solidFill>
-                  <a:srgbClr val="D7E3EC"/>
-                </a:solidFill>
-                <a:latin typeface="Calibri"/>
-              </a:rPr>
-              <a:t>•  Nothing here was compiled or flashed -- editing a flowgraph and rerunning it is the entire iteration loop.</a:t>
-            </a:r>
-          </a:p>
-          <a:p>
-            <a:pPr>
-              <a:lnSpc>
-                <a:spcPct val="112000"/>
-              </a:lnSpc>
-              <a:spcAft>
-                <a:spcPts val="1000"/>
-              </a:spcAft>
-            </a:pPr>
-            <a:r>
-              <a:rPr sz="1500">
-                <a:solidFill>
-                  <a:srgbClr val="D7E3EC"/>
-                </a:solidFill>
-                <a:latin typeface="Calibri"/>
-              </a:rPr>
-              <a:t>•  The .grc files themselves are plain text -- that's why this whole demo kit lives in a git repo.</a:t>
-            </a:r>
-          </a:p>
-        </p:txBody>
-      </p:sp>
-      <p:sp>
-        <p:nvSpPr>
-          <p:cNvPr id="12" name="TextBox 11"/>
-          <p:cNvSpPr txBox="1"/>
-          <p:nvPr/>
-        </p:nvSpPr>
-        <p:spPr>
-          <a:xfrm>
-            <a:off x="640080" y="6473952"/>
-            <a:ext cx="8229600" cy="274320"/>
-          </a:xfrm>
-          <a:prstGeom prst="rect">
-            <a:avLst/>
-          </a:prstGeom>
-          <a:noFill/>
-        </p:spPr>
-        <p:txBody>
-          <a:bodyPr wrap="square" anchor="t" lIns="0" rIns="0" tIns="0" bIns="0">
-            <a:spAutoFit/>
-          </a:bodyPr>
-          <a:lstStyle/>
-          <a:p>
-            <a:pPr algn="l">
-              <a:lnSpc>
-                <a:spcPct val="115000"/>
-              </a:lnSpc>
-            </a:pPr>
-            <a:r>
-              <a:rPr sz="1000" b="0" i="1">
-                <a:solidFill>
-                  <a:srgbClr val="8EA7BA"/>
-                </a:solidFill>
-                <a:latin typeface="Calibri"/>
-              </a:rPr>
-              <a:t>Source: gnuradio.org -- GNU Radio Conference (GRCon) happens every year</a:t>
-            </a:r>
-          </a:p>
-        </p:txBody>
-      </p:sp>
-      <p:sp>
-        <p:nvSpPr>
-          <p:cNvPr id="13" name="TextBox 12"/>
           <p:cNvSpPr txBox="1"/>
           <p:nvPr/>
         </p:nvSpPr>

</xml_diff>

<commit_message>
slides: add pysdr.org roadmap slide after 'Go Build Something'
New slide 21, 'Learn the DSP, in Python: pysdr.org' -- kicker 'Software
Defined Radio Requires Software'. A four-step roadmap (Fourier
Transforms -> Filters -> Digital Modulation -> RX & TX in Python)
through pysdr.org's own chapters, framed as the Python-first complement
to GNU Radio Companion's drag-and-drop canvas used all night. Explicitly
callbacks to the two earlier pysdr.org citations in this deck (slide 3,
noise; slide 17, bandwidth/Nyquist) to tie the whole talk's sourcing
together. 'Thank You' pushed to slide 22; deck is now 22 slides.

Updated PRESENTER_NOTES.md's table and README's slide count.

Co-Authored-By: Claude Sonnet 5 <noreply@anthropic.com>
</commit_message>
<xml_diff>
--- a/slides/SDR_Demo.pptx
+++ b/slides/SDR_Demo.pptx
@@ -26,6 +26,7 @@
     <p:sldId id="274" r:id="rId25"/>
     <p:sldId id="275" r:id="rId26"/>
     <p:sldId id="276" r:id="rId27"/>
+    <p:sldId id="277" r:id="rId28"/>
   </p:sldIdLst>
   <p:sldSz cx="12191695" cy="6858000" type="screen4x3"/>
   <p:notesSz cx="6858000" cy="9144000"/>
@@ -3744,7 +3745,7 @@
                 </a:solidFill>
                 <a:latin typeface="Calibri"/>
               </a:rPr>
-              <a:t>9 / 21</a:t>
+              <a:t>9 / 22</a:t>
             </a:r>
           </a:p>
         </p:txBody>
@@ -4124,7 +4125,7 @@
                 </a:solidFill>
                 <a:latin typeface="Calibri"/>
               </a:rPr>
-              <a:t>10 / 21</a:t>
+              <a:t>10 / 22</a:t>
             </a:r>
           </a:p>
         </p:txBody>
@@ -4482,7 +4483,7 @@
                 </a:solidFill>
                 <a:latin typeface="Calibri"/>
               </a:rPr>
-              <a:t>11 / 21</a:t>
+              <a:t>11 / 22</a:t>
             </a:r>
           </a:p>
         </p:txBody>
@@ -4879,7 +4880,7 @@
                 </a:solidFill>
                 <a:latin typeface="Calibri"/>
               </a:rPr>
-              <a:t>12 / 21</a:t>
+              <a:t>12 / 22</a:t>
             </a:r>
           </a:p>
         </p:txBody>
@@ -5257,7 +5258,7 @@
                 </a:solidFill>
                 <a:latin typeface="Calibri"/>
               </a:rPr>
-              <a:t>13 / 21</a:t>
+              <a:t>13 / 22</a:t>
             </a:r>
           </a:p>
         </p:txBody>
@@ -5776,7 +5777,7 @@
                 </a:solidFill>
                 <a:latin typeface="Calibri"/>
               </a:rPr>
-              <a:t>14 / 21</a:t>
+              <a:t>14 / 22</a:t>
             </a:r>
           </a:p>
         </p:txBody>
@@ -6396,7 +6397,7 @@
                 </a:solidFill>
                 <a:latin typeface="Calibri"/>
               </a:rPr>
-              <a:t>15 / 21</a:t>
+              <a:t>15 / 22</a:t>
             </a:r>
           </a:p>
         </p:txBody>
@@ -7159,7 +7160,7 @@
                 </a:solidFill>
                 <a:latin typeface="Calibri"/>
               </a:rPr>
-              <a:t>16 / 21</a:t>
+              <a:t>16 / 22</a:t>
             </a:r>
           </a:p>
         </p:txBody>
@@ -7736,7 +7737,7 @@
                 </a:solidFill>
                 <a:latin typeface="Calibri"/>
               </a:rPr>
-              <a:t>17 / 21</a:t>
+              <a:t>17 / 22</a:t>
             </a:r>
           </a:p>
         </p:txBody>
@@ -8852,7 +8853,7 @@
                 </a:solidFill>
                 <a:latin typeface="Calibri"/>
               </a:rPr>
-              <a:t>18 / 21</a:t>
+              <a:t>18 / 22</a:t>
             </a:r>
           </a:p>
         </p:txBody>
@@ -10051,7 +10052,7 @@
                 </a:solidFill>
                 <a:latin typeface="Calibri"/>
               </a:rPr>
-              <a:t>1 / 21</a:t>
+              <a:t>1 / 22</a:t>
             </a:r>
           </a:p>
         </p:txBody>
@@ -10511,7 +10512,7 @@
                 </a:solidFill>
                 <a:latin typeface="Calibri"/>
               </a:rPr>
-              <a:t>19 / 21</a:t>
+              <a:t>19 / 22</a:t>
             </a:r>
           </a:p>
         </p:txBody>
@@ -10586,6 +10587,791 @@
         </p:nvSpPr>
         <p:spPr>
           <a:xfrm>
+            <a:off x="640080" y="457200"/>
+            <a:ext cx="10881360" cy="365760"/>
+          </a:xfrm>
+          <a:prstGeom prst="rect">
+            <a:avLst/>
+          </a:prstGeom>
+          <a:noFill/>
+        </p:spPr>
+        <p:txBody>
+          <a:bodyPr wrap="square" anchor="t" lIns="0" rIns="0" tIns="0" bIns="0">
+            <a:spAutoFit/>
+          </a:bodyPr>
+          <a:lstStyle/>
+          <a:p>
+            <a:pPr algn="l">
+              <a:lnSpc>
+                <a:spcPct val="115000"/>
+              </a:lnSpc>
+            </a:pPr>
+            <a:r>
+              <a:rPr sz="1400" b="1" i="0">
+                <a:solidFill>
+                  <a:srgbClr val="35D0BA"/>
+                </a:solidFill>
+                <a:latin typeface="Calibri"/>
+              </a:rPr>
+              <a:t>SOFTWARE DEFINED RADIO REQUIRES SOFTWARE</a:t>
+            </a:r>
+          </a:p>
+        </p:txBody>
+      </p:sp>
+      <p:sp>
+        <p:nvSpPr>
+          <p:cNvPr id="4" name="TextBox 3"/>
+          <p:cNvSpPr txBox="1"/>
+          <p:nvPr/>
+        </p:nvSpPr>
+        <p:spPr>
+          <a:xfrm>
+            <a:off x="640080" y="786384"/>
+            <a:ext cx="10881360" cy="822960"/>
+          </a:xfrm>
+          <a:prstGeom prst="rect">
+            <a:avLst/>
+          </a:prstGeom>
+          <a:noFill/>
+        </p:spPr>
+        <p:txBody>
+          <a:bodyPr wrap="square" anchor="t" lIns="0" rIns="0" tIns="0" bIns="0">
+            <a:spAutoFit/>
+          </a:bodyPr>
+          <a:lstStyle/>
+          <a:p>
+            <a:pPr algn="l">
+              <a:lnSpc>
+                <a:spcPct val="115000"/>
+              </a:lnSpc>
+            </a:pPr>
+            <a:r>
+              <a:rPr sz="3200" b="1" i="0">
+                <a:solidFill>
+                  <a:srgbClr val="FFFFFF"/>
+                </a:solidFill>
+                <a:latin typeface="Calibri"/>
+              </a:rPr>
+              <a:t>Learn the DSP, in Python: pysdr.org</a:t>
+            </a:r>
+          </a:p>
+        </p:txBody>
+      </p:sp>
+      <p:sp>
+        <p:nvSpPr>
+          <p:cNvPr id="5" name="Rectangle 4"/>
+          <p:cNvSpPr/>
+          <p:nvPr/>
+        </p:nvSpPr>
+        <p:spPr>
+          <a:xfrm>
+            <a:off x="640080" y="1481328"/>
+            <a:ext cx="1005840" cy="50800"/>
+          </a:xfrm>
+          <a:prstGeom prst="rect">
+            <a:avLst/>
+          </a:prstGeom>
+          <a:solidFill>
+            <a:srgbClr val="35D0BA"/>
+          </a:solidFill>
+          <a:ln>
+            <a:noFill/>
+          </a:ln>
+          <a:effectLst/>
+        </p:spPr>
+        <p:style>
+          <a:lnRef idx="1">
+            <a:schemeClr val="accent1"/>
+          </a:lnRef>
+          <a:fillRef idx="3">
+            <a:schemeClr val="accent1"/>
+          </a:fillRef>
+          <a:effectRef idx="2">
+            <a:schemeClr val="accent1"/>
+          </a:effectRef>
+          <a:fontRef idx="minor">
+            <a:schemeClr val="lt1"/>
+          </a:fontRef>
+        </p:style>
+        <p:txBody>
+          <a:bodyPr rtlCol="0" anchor="ctr"/>
+          <a:lstStyle/>
+          <a:p>
+            <a:pPr algn="ctr"/>
+          </a:p>
+        </p:txBody>
+      </p:sp>
+      <p:sp>
+        <p:nvSpPr>
+          <p:cNvPr id="6" name="TextBox 5"/>
+          <p:cNvSpPr txBox="1"/>
+          <p:nvPr/>
+        </p:nvSpPr>
+        <p:spPr>
+          <a:xfrm>
+            <a:off x="640080" y="1920240"/>
+            <a:ext cx="10698480" cy="1051560"/>
+          </a:xfrm>
+          <a:prstGeom prst="rect">
+            <a:avLst/>
+          </a:prstGeom>
+          <a:noFill/>
+        </p:spPr>
+        <p:txBody>
+          <a:bodyPr wrap="square">
+            <a:spAutoFit/>
+          </a:bodyPr>
+          <a:lstStyle/>
+          <a:p>
+            <a:pPr>
+              <a:lnSpc>
+                <a:spcPct val="112000"/>
+              </a:lnSpc>
+              <a:spcAft>
+                <a:spcPts val="1000"/>
+              </a:spcAft>
+            </a:pPr>
+            <a:r>
+              <a:rPr sz="1600">
+                <a:solidFill>
+                  <a:srgbClr val="D7E3EC"/>
+                </a:solidFill>
+                <a:latin typeface="Calibri"/>
+              </a:rPr>
+              <a:t>•  Everything tonight ran through GNU Radio Companion's drag-and-drop canvas -- pysdr.org teaches the same DSP by writing the Python (NumPy/SciPy) yourself, concept by concept.</a:t>
+            </a:r>
+          </a:p>
+          <a:p>
+            <a:pPr>
+              <a:lnSpc>
+                <a:spcPct val="112000"/>
+              </a:lnSpc>
+              <a:spcAft>
+                <a:spcPts val="1000"/>
+              </a:spcAft>
+            </a:pPr>
+            <a:r>
+              <a:rPr sz="1600">
+                <a:solidFill>
+                  <a:srgbClr val="D7E3EC"/>
+                </a:solidFill>
+                <a:latin typeface="Calibri"/>
+              </a:rPr>
+              <a:t>•  Free, written for engineers, no textbook required first -- the same site cited earlier tonight for noise (slide 3) and bandwidth/Nyquist (slide 17).</a:t>
+            </a:r>
+          </a:p>
+        </p:txBody>
+      </p:sp>
+      <p:sp>
+        <p:nvSpPr>
+          <p:cNvPr id="7" name="Rounded Rectangle 6"/>
+          <p:cNvSpPr/>
+          <p:nvPr/>
+        </p:nvSpPr>
+        <p:spPr>
+          <a:xfrm>
+            <a:off x="678027" y="3383280"/>
+            <a:ext cx="2331720" cy="1005840"/>
+          </a:xfrm>
+          <a:prstGeom prst="roundRect">
+            <a:avLst>
+              <a:gd name="adj" fmla="val 12000"/>
+            </a:avLst>
+          </a:prstGeom>
+          <a:solidFill>
+            <a:srgbClr val="1B5E58"/>
+          </a:solidFill>
+          <a:ln w="15875">
+            <a:solidFill>
+              <a:srgbClr val="35D0BA"/>
+            </a:solidFill>
+          </a:ln>
+          <a:effectLst/>
+        </p:spPr>
+        <p:style>
+          <a:lnRef idx="1">
+            <a:schemeClr val="accent1"/>
+          </a:lnRef>
+          <a:fillRef idx="3">
+            <a:schemeClr val="accent1"/>
+          </a:fillRef>
+          <a:effectRef idx="2">
+            <a:schemeClr val="accent1"/>
+          </a:effectRef>
+          <a:fontRef idx="minor">
+            <a:schemeClr val="lt1"/>
+          </a:fontRef>
+        </p:style>
+        <p:txBody>
+          <a:bodyPr rtlCol="0" anchor="ctr"/>
+          <a:lstStyle/>
+          <a:p>
+            <a:pPr algn="ctr"/>
+            <a:r>
+              <a:rPr sz="1500" b="1">
+                <a:solidFill>
+                  <a:srgbClr val="FFFFFF"/>
+                </a:solidFill>
+                <a:latin typeface="Calibri"/>
+              </a:rPr>
+              <a:t>Fourier
+Transforms</a:t>
+            </a:r>
+          </a:p>
+        </p:txBody>
+      </p:sp>
+      <p:sp>
+        <p:nvSpPr>
+          <p:cNvPr id="8" name="Right Arrow 7"/>
+          <p:cNvSpPr/>
+          <p:nvPr/>
+        </p:nvSpPr>
+        <p:spPr>
+          <a:xfrm>
+            <a:off x="3009747" y="3730752"/>
+            <a:ext cx="502920" cy="310896"/>
+          </a:xfrm>
+          <a:prstGeom prst="rightArrow">
+            <a:avLst/>
+          </a:prstGeom>
+          <a:solidFill>
+            <a:srgbClr val="35D0BA"/>
+          </a:solidFill>
+          <a:ln>
+            <a:noFill/>
+          </a:ln>
+          <a:effectLst/>
+        </p:spPr>
+        <p:style>
+          <a:lnRef idx="1">
+            <a:schemeClr val="accent1"/>
+          </a:lnRef>
+          <a:fillRef idx="3">
+            <a:schemeClr val="accent1"/>
+          </a:fillRef>
+          <a:effectRef idx="2">
+            <a:schemeClr val="accent1"/>
+          </a:effectRef>
+          <a:fontRef idx="minor">
+            <a:schemeClr val="lt1"/>
+          </a:fontRef>
+        </p:style>
+        <p:txBody>
+          <a:bodyPr rtlCol="0" anchor="ctr"/>
+          <a:lstStyle/>
+          <a:p>
+            <a:pPr algn="ctr"/>
+          </a:p>
+        </p:txBody>
+      </p:sp>
+      <p:sp>
+        <p:nvSpPr>
+          <p:cNvPr id="9" name="Rounded Rectangle 8"/>
+          <p:cNvSpPr/>
+          <p:nvPr/>
+        </p:nvSpPr>
+        <p:spPr>
+          <a:xfrm>
+            <a:off x="3512667" y="3383280"/>
+            <a:ext cx="2331720" cy="1005840"/>
+          </a:xfrm>
+          <a:prstGeom prst="roundRect">
+            <a:avLst>
+              <a:gd name="adj" fmla="val 12000"/>
+            </a:avLst>
+          </a:prstGeom>
+          <a:solidFill>
+            <a:srgbClr val="0F2438"/>
+          </a:solidFill>
+          <a:ln w="15875">
+            <a:solidFill>
+              <a:srgbClr val="35D0BA"/>
+            </a:solidFill>
+          </a:ln>
+          <a:effectLst/>
+        </p:spPr>
+        <p:style>
+          <a:lnRef idx="1">
+            <a:schemeClr val="accent1"/>
+          </a:lnRef>
+          <a:fillRef idx="3">
+            <a:schemeClr val="accent1"/>
+          </a:fillRef>
+          <a:effectRef idx="2">
+            <a:schemeClr val="accent1"/>
+          </a:effectRef>
+          <a:fontRef idx="minor">
+            <a:schemeClr val="lt1"/>
+          </a:fontRef>
+        </p:style>
+        <p:txBody>
+          <a:bodyPr rtlCol="0" anchor="ctr"/>
+          <a:lstStyle/>
+          <a:p>
+            <a:pPr algn="ctr"/>
+            <a:r>
+              <a:rPr sz="1500" b="1">
+                <a:solidFill>
+                  <a:srgbClr val="FFFFFF"/>
+                </a:solidFill>
+                <a:latin typeface="Calibri"/>
+              </a:rPr>
+              <a:t>Filters</a:t>
+            </a:r>
+          </a:p>
+        </p:txBody>
+      </p:sp>
+      <p:sp>
+        <p:nvSpPr>
+          <p:cNvPr id="10" name="Right Arrow 9"/>
+          <p:cNvSpPr/>
+          <p:nvPr/>
+        </p:nvSpPr>
+        <p:spPr>
+          <a:xfrm>
+            <a:off x="5844387" y="3730752"/>
+            <a:ext cx="502920" cy="310896"/>
+          </a:xfrm>
+          <a:prstGeom prst="rightArrow">
+            <a:avLst/>
+          </a:prstGeom>
+          <a:solidFill>
+            <a:srgbClr val="35D0BA"/>
+          </a:solidFill>
+          <a:ln>
+            <a:noFill/>
+          </a:ln>
+          <a:effectLst/>
+        </p:spPr>
+        <p:style>
+          <a:lnRef idx="1">
+            <a:schemeClr val="accent1"/>
+          </a:lnRef>
+          <a:fillRef idx="3">
+            <a:schemeClr val="accent1"/>
+          </a:fillRef>
+          <a:effectRef idx="2">
+            <a:schemeClr val="accent1"/>
+          </a:effectRef>
+          <a:fontRef idx="minor">
+            <a:schemeClr val="lt1"/>
+          </a:fontRef>
+        </p:style>
+        <p:txBody>
+          <a:bodyPr rtlCol="0" anchor="ctr"/>
+          <a:lstStyle/>
+          <a:p>
+            <a:pPr algn="ctr"/>
+          </a:p>
+        </p:txBody>
+      </p:sp>
+      <p:sp>
+        <p:nvSpPr>
+          <p:cNvPr id="11" name="Rounded Rectangle 10"/>
+          <p:cNvSpPr/>
+          <p:nvPr/>
+        </p:nvSpPr>
+        <p:spPr>
+          <a:xfrm>
+            <a:off x="6347307" y="3383280"/>
+            <a:ext cx="2331720" cy="1005840"/>
+          </a:xfrm>
+          <a:prstGeom prst="roundRect">
+            <a:avLst>
+              <a:gd name="adj" fmla="val 12000"/>
+            </a:avLst>
+          </a:prstGeom>
+          <a:solidFill>
+            <a:srgbClr val="0F2438"/>
+          </a:solidFill>
+          <a:ln w="15875">
+            <a:solidFill>
+              <a:srgbClr val="35D0BA"/>
+            </a:solidFill>
+          </a:ln>
+          <a:effectLst/>
+        </p:spPr>
+        <p:style>
+          <a:lnRef idx="1">
+            <a:schemeClr val="accent1"/>
+          </a:lnRef>
+          <a:fillRef idx="3">
+            <a:schemeClr val="accent1"/>
+          </a:fillRef>
+          <a:effectRef idx="2">
+            <a:schemeClr val="accent1"/>
+          </a:effectRef>
+          <a:fontRef idx="minor">
+            <a:schemeClr val="lt1"/>
+          </a:fontRef>
+        </p:style>
+        <p:txBody>
+          <a:bodyPr rtlCol="0" anchor="ctr"/>
+          <a:lstStyle/>
+          <a:p>
+            <a:pPr algn="ctr"/>
+            <a:r>
+              <a:rPr sz="1500" b="1">
+                <a:solidFill>
+                  <a:srgbClr val="FFFFFF"/>
+                </a:solidFill>
+                <a:latin typeface="Calibri"/>
+              </a:rPr>
+              <a:t>Digital
+Modulation</a:t>
+            </a:r>
+          </a:p>
+        </p:txBody>
+      </p:sp>
+      <p:sp>
+        <p:nvSpPr>
+          <p:cNvPr id="12" name="Right Arrow 11"/>
+          <p:cNvSpPr/>
+          <p:nvPr/>
+        </p:nvSpPr>
+        <p:spPr>
+          <a:xfrm>
+            <a:off x="8679027" y="3730752"/>
+            <a:ext cx="502920" cy="310896"/>
+          </a:xfrm>
+          <a:prstGeom prst="rightArrow">
+            <a:avLst/>
+          </a:prstGeom>
+          <a:solidFill>
+            <a:srgbClr val="35D0BA"/>
+          </a:solidFill>
+          <a:ln>
+            <a:noFill/>
+          </a:ln>
+          <a:effectLst/>
+        </p:spPr>
+        <p:style>
+          <a:lnRef idx="1">
+            <a:schemeClr val="accent1"/>
+          </a:lnRef>
+          <a:fillRef idx="3">
+            <a:schemeClr val="accent1"/>
+          </a:fillRef>
+          <a:effectRef idx="2">
+            <a:schemeClr val="accent1"/>
+          </a:effectRef>
+          <a:fontRef idx="minor">
+            <a:schemeClr val="lt1"/>
+          </a:fontRef>
+        </p:style>
+        <p:txBody>
+          <a:bodyPr rtlCol="0" anchor="ctr"/>
+          <a:lstStyle/>
+          <a:p>
+            <a:pPr algn="ctr"/>
+          </a:p>
+        </p:txBody>
+      </p:sp>
+      <p:sp>
+        <p:nvSpPr>
+          <p:cNvPr id="13" name="Rounded Rectangle 12"/>
+          <p:cNvSpPr/>
+          <p:nvPr/>
+        </p:nvSpPr>
+        <p:spPr>
+          <a:xfrm>
+            <a:off x="9181947" y="3383280"/>
+            <a:ext cx="2331720" cy="1005840"/>
+          </a:xfrm>
+          <a:prstGeom prst="roundRect">
+            <a:avLst>
+              <a:gd name="adj" fmla="val 12000"/>
+            </a:avLst>
+          </a:prstGeom>
+          <a:solidFill>
+            <a:srgbClr val="1B5E58"/>
+          </a:solidFill>
+          <a:ln w="15875">
+            <a:solidFill>
+              <a:srgbClr val="35D0BA"/>
+            </a:solidFill>
+          </a:ln>
+          <a:effectLst/>
+        </p:spPr>
+        <p:style>
+          <a:lnRef idx="1">
+            <a:schemeClr val="accent1"/>
+          </a:lnRef>
+          <a:fillRef idx="3">
+            <a:schemeClr val="accent1"/>
+          </a:fillRef>
+          <a:effectRef idx="2">
+            <a:schemeClr val="accent1"/>
+          </a:effectRef>
+          <a:fontRef idx="minor">
+            <a:schemeClr val="lt1"/>
+          </a:fontRef>
+        </p:style>
+        <p:txBody>
+          <a:bodyPr rtlCol="0" anchor="ctr"/>
+          <a:lstStyle/>
+          <a:p>
+            <a:pPr algn="ctr"/>
+            <a:r>
+              <a:rPr sz="1500" b="1">
+                <a:solidFill>
+                  <a:srgbClr val="FFFFFF"/>
+                </a:solidFill>
+                <a:latin typeface="Calibri"/>
+              </a:rPr>
+              <a:t>RX &amp; TX
+in Python</a:t>
+            </a:r>
+          </a:p>
+        </p:txBody>
+      </p:sp>
+      <p:sp>
+        <p:nvSpPr>
+          <p:cNvPr id="14" name="TextBox 13"/>
+          <p:cNvSpPr txBox="1"/>
+          <p:nvPr/>
+        </p:nvSpPr>
+        <p:spPr>
+          <a:xfrm>
+            <a:off x="640080" y="4709160"/>
+            <a:ext cx="10698480" cy="1463040"/>
+          </a:xfrm>
+          <a:prstGeom prst="rect">
+            <a:avLst/>
+          </a:prstGeom>
+          <a:noFill/>
+        </p:spPr>
+        <p:txBody>
+          <a:bodyPr wrap="square">
+            <a:spAutoFit/>
+          </a:bodyPr>
+          <a:lstStyle/>
+          <a:p>
+            <a:pPr>
+              <a:lnSpc>
+                <a:spcPct val="112000"/>
+              </a:lnSpc>
+              <a:spcAft>
+                <a:spcPts val="400"/>
+              </a:spcAft>
+            </a:pPr>
+            <a:r>
+              <a:rPr sz="1300">
+                <a:solidFill>
+                  <a:srgbClr val="D7E3EC"/>
+                </a:solidFill>
+                <a:latin typeface="Calibri"/>
+              </a:rPr>
+              <a:t>•  Fourier Transforms: the FFT math behind every spectrum plot and waterfall shown tonight.</a:t>
+            </a:r>
+          </a:p>
+          <a:p>
+            <a:pPr>
+              <a:lnSpc>
+                <a:spcPct val="112000"/>
+              </a:lnSpc>
+              <a:spcAft>
+                <a:spcPts val="400"/>
+              </a:spcAft>
+            </a:pPr>
+            <a:r>
+              <a:rPr sz="1300">
+                <a:solidFill>
+                  <a:srgbClr val="D7E3EC"/>
+                </a:solidFill>
+                <a:latin typeface="Calibri"/>
+              </a:rPr>
+              <a:t>•  Filters: the same low-pass/channel-select filtering every flowgraph tonight used, written out by hand.</a:t>
+            </a:r>
+          </a:p>
+          <a:p>
+            <a:pPr>
+              <a:lnSpc>
+                <a:spcPct val="112000"/>
+              </a:lnSpc>
+              <a:spcAft>
+                <a:spcPts val="400"/>
+              </a:spcAft>
+            </a:pPr>
+            <a:r>
+              <a:rPr sz="1300">
+                <a:solidFill>
+                  <a:srgbClr val="D7E3EC"/>
+                </a:solidFill>
+                <a:latin typeface="Calibri"/>
+              </a:rPr>
+              <a:t>•  Digital Modulation: ASK, PSK, QAM, FSK -- how bits become RF, from first principles.</a:t>
+            </a:r>
+          </a:p>
+          <a:p>
+            <a:pPr>
+              <a:lnSpc>
+                <a:spcPct val="112000"/>
+              </a:lnSpc>
+              <a:spcAft>
+                <a:spcPts val="400"/>
+              </a:spcAft>
+            </a:pPr>
+            <a:r>
+              <a:rPr sz="1300">
+                <a:solidFill>
+                  <a:srgbClr val="D7E3EC"/>
+                </a:solidFill>
+                <a:latin typeface="Calibri"/>
+              </a:rPr>
+              <a:t>•  RX &amp; TX in Python: PlutoSDR, USRP, RTL-SDR, and HackRF, each driven directly from a Python script -- no GRC canvas required.</a:t>
+            </a:r>
+          </a:p>
+        </p:txBody>
+      </p:sp>
+      <p:sp>
+        <p:nvSpPr>
+          <p:cNvPr id="15" name="TextBox 14"/>
+          <p:cNvSpPr txBox="1"/>
+          <p:nvPr/>
+        </p:nvSpPr>
+        <p:spPr>
+          <a:xfrm>
+            <a:off x="640080" y="6473952"/>
+            <a:ext cx="8229600" cy="274320"/>
+          </a:xfrm>
+          <a:prstGeom prst="rect">
+            <a:avLst/>
+          </a:prstGeom>
+          <a:noFill/>
+        </p:spPr>
+        <p:txBody>
+          <a:bodyPr wrap="square" anchor="t" lIns="0" rIns="0" tIns="0" bIns="0">
+            <a:spAutoFit/>
+          </a:bodyPr>
+          <a:lstStyle/>
+          <a:p>
+            <a:pPr algn="l">
+              <a:lnSpc>
+                <a:spcPct val="115000"/>
+              </a:lnSpc>
+            </a:pPr>
+            <a:r>
+              <a:rPr sz="1000" b="0" i="1">
+                <a:solidFill>
+                  <a:srgbClr val="8EA7BA"/>
+                </a:solidFill>
+                <a:latin typeface="Calibri"/>
+              </a:rPr>
+              <a:t>pysdr.org -- "A Guide to SDR and DSP using Python"</a:t>
+            </a:r>
+          </a:p>
+        </p:txBody>
+      </p:sp>
+      <p:sp>
+        <p:nvSpPr>
+          <p:cNvPr id="16" name="TextBox 15"/>
+          <p:cNvSpPr txBox="1"/>
+          <p:nvPr/>
+        </p:nvSpPr>
+        <p:spPr>
+          <a:xfrm>
+            <a:off x="11292840" y="6473952"/>
+            <a:ext cx="731520" cy="274320"/>
+          </a:xfrm>
+          <a:prstGeom prst="rect">
+            <a:avLst/>
+          </a:prstGeom>
+          <a:noFill/>
+        </p:spPr>
+        <p:txBody>
+          <a:bodyPr wrap="square" anchor="t" lIns="0" rIns="0" tIns="0" bIns="0">
+            <a:spAutoFit/>
+          </a:bodyPr>
+          <a:lstStyle/>
+          <a:p>
+            <a:pPr algn="r">
+              <a:lnSpc>
+                <a:spcPct val="115000"/>
+              </a:lnSpc>
+            </a:pPr>
+            <a:r>
+              <a:rPr sz="1000" b="0" i="0">
+                <a:solidFill>
+                  <a:srgbClr val="8EA7BA"/>
+                </a:solidFill>
+                <a:latin typeface="Calibri"/>
+              </a:rPr>
+              <a:t>20 / 22</a:t>
+            </a:r>
+          </a:p>
+        </p:txBody>
+      </p:sp>
+    </p:spTree>
+  </p:cSld>
+  <p:clrMapOvr>
+    <a:masterClrMapping/>
+  </p:clrMapOvr>
+</p:sld>
+</file>
+
+<file path=ppt/slides/slide22.xml><?xml version="1.0" encoding="utf-8"?>
+<p:sld xmlns:a="http://schemas.openxmlformats.org/drawingml/2006/main" xmlns:p="http://schemas.openxmlformats.org/presentationml/2006/main" xmlns:r="http://schemas.openxmlformats.org/officeDocument/2006/relationships">
+  <p:cSld>
+    <p:spTree>
+      <p:nvGrpSpPr>
+        <p:cNvPr id="1" name=""/>
+        <p:cNvGrpSpPr/>
+        <p:nvPr/>
+      </p:nvGrpSpPr>
+      <p:grpSpPr/>
+      <p:sp>
+        <p:nvSpPr>
+          <p:cNvPr id="2" name="Rectangle 1"/>
+          <p:cNvSpPr/>
+          <p:nvPr/>
+        </p:nvSpPr>
+        <p:spPr>
+          <a:xfrm>
+            <a:off x="0" y="0"/>
+            <a:ext cx="12191695" cy="6858000"/>
+          </a:xfrm>
+          <a:prstGeom prst="rect">
+            <a:avLst/>
+          </a:prstGeom>
+          <a:solidFill>
+            <a:srgbClr val="0A1929"/>
+          </a:solidFill>
+          <a:ln>
+            <a:noFill/>
+          </a:ln>
+          <a:effectLst/>
+        </p:spPr>
+        <p:style>
+          <a:lnRef idx="1">
+            <a:schemeClr val="accent1"/>
+          </a:lnRef>
+          <a:fillRef idx="3">
+            <a:schemeClr val="accent1"/>
+          </a:fillRef>
+          <a:effectRef idx="2">
+            <a:schemeClr val="accent1"/>
+          </a:effectRef>
+          <a:fontRef idx="minor">
+            <a:schemeClr val="lt1"/>
+          </a:fontRef>
+        </p:style>
+        <p:txBody>
+          <a:bodyPr rtlCol="0" anchor="ctr"/>
+          <a:lstStyle/>
+          <a:p>
+            <a:pPr algn="ctr"/>
+          </a:p>
+        </p:txBody>
+      </p:sp>
+      <p:sp>
+        <p:nvSpPr>
+          <p:cNvPr id="3" name="TextBox 2"/>
+          <p:cNvSpPr txBox="1"/>
+          <p:nvPr/>
+        </p:nvSpPr>
+        <p:spPr>
+          <a:xfrm>
             <a:off x="822960" y="2651760"/>
             <a:ext cx="10515600" cy="1097280"/>
           </a:xfrm>
@@ -11407,7 +12193,7 @@
                 </a:solidFill>
                 <a:latin typeface="Calibri"/>
               </a:rPr>
-              <a:t>2 / 21</a:t>
+              <a:t>2 / 22</a:t>
             </a:r>
           </a:p>
         </p:txBody>
@@ -12107,7 +12893,7 @@
                 </a:solidFill>
                 <a:latin typeface="Calibri"/>
               </a:rPr>
-              <a:t>3 / 21</a:t>
+              <a:t>3 / 22</a:t>
             </a:r>
           </a:p>
         </p:txBody>
@@ -12760,7 +13546,7 @@
                 </a:solidFill>
                 <a:latin typeface="Calibri"/>
               </a:rPr>
-              <a:t>4 / 21</a:t>
+              <a:t>4 / 22</a:t>
             </a:r>
           </a:p>
         </p:txBody>
@@ -13659,7 +14445,7 @@
                 </a:solidFill>
                 <a:latin typeface="Calibri"/>
               </a:rPr>
-              <a:t>5 / 21</a:t>
+              <a:t>5 / 22</a:t>
             </a:r>
           </a:p>
         </p:txBody>
@@ -14388,7 +15174,7 @@
                 </a:solidFill>
                 <a:latin typeface="Calibri"/>
               </a:rPr>
-              <a:t>6 / 21</a:t>
+              <a:t>6 / 22</a:t>
             </a:r>
           </a:p>
         </p:txBody>
@@ -14790,7 +15576,7 @@
                 </a:solidFill>
                 <a:latin typeface="Calibri"/>
               </a:rPr>
-              <a:t>7 / 21</a:t>
+              <a:t>7 / 22</a:t>
             </a:r>
           </a:p>
         </p:txBody>
@@ -15187,7 +15973,7 @@
                 </a:solidFill>
                 <a:latin typeface="Calibri"/>
               </a:rPr>
-              <a:t>8 / 21</a:t>
+              <a:t>8 / 22</a:t>
             </a:r>
           </a:p>
         </p:txBody>

</xml_diff>

<commit_message>
slides: link argilo/sdr-examples on slide 18 (More Demo Ideas)
Added a clickable hyperlink to github.com/argilo/sdr-examples -- a ham
club GNU Radio tutorial repo with working flowgraphs for several of the
modes already listed on this slide (WSPR, DMR, D-STAR, and more).
Dropped the slide's standard footer() call to make room without
overlapping the new line; page number still renders correctly.

Co-Authored-By: Claude Sonnet 5 <noreply@anthropic.com>
</commit_message>
<xml_diff>
--- a/slides/SDR_Demo.pptx
+++ b/slides/SDR_Demo.pptx
@@ -7633,8 +7633,8 @@
         </p:nvSpPr>
         <p:spPr>
           <a:xfrm>
-            <a:off x="640080" y="5943600"/>
-            <a:ext cx="10058400" cy="365760"/>
+            <a:off x="640080" y="5897880"/>
+            <a:ext cx="10058400" cy="274320"/>
           </a:xfrm>
           <a:prstGeom prst="rect">
             <a:avLst/>
@@ -7672,8 +7672,8 @@
         </p:nvSpPr>
         <p:spPr>
           <a:xfrm>
-            <a:off x="640080" y="6473952"/>
-            <a:ext cx="7315200" cy="274320"/>
+            <a:off x="640080" y="6199632"/>
+            <a:ext cx="10881360" cy="274320"/>
           </a:xfrm>
           <a:prstGeom prst="rect">
             <a:avLst/>
@@ -7681,24 +7681,26 @@
           <a:noFill/>
         </p:spPr>
         <p:txBody>
-          <a:bodyPr wrap="square" anchor="t" lIns="0" rIns="0" tIns="0" bIns="0">
+          <a:bodyPr wrap="square">
             <a:spAutoFit/>
           </a:bodyPr>
           <a:lstStyle/>
           <a:p>
-            <a:pPr algn="l">
-              <a:lnSpc>
-                <a:spcPct val="115000"/>
-              </a:lnSpc>
-            </a:pPr>
-            <a:r>
-              <a:rPr sz="1000" b="0" i="0">
+            <a:r>
+              <a:rPr sz="1300" i="1">
                 <a:solidFill>
                   <a:srgbClr val="8EA7BA"/>
                 </a:solidFill>
                 <a:latin typeface="Calibri"/>
               </a:rPr>
-              <a:t>SDR Demo -- GNU Radio + HackRF + Ham Handheld</a:t>
+              <a:t>Working GNU Radio flowgraphs for many of these modes (ham club tutorial repo): </a:t>
+            </a:r>
+            <a:r>
+              <a:rPr sz="1300" i="1">
+                <a:latin typeface="Calibri"/>
+                <a:hlinkClick r:id="rId2"/>
+              </a:rPr>
+              <a:t>github.com/argilo/sdr-examples</a:t>
             </a:r>
           </a:p>
         </p:txBody>

</xml_diff>